<commit_message>
Fixed stale documentation numbers: comments referring to 2,002 sprints / 363 zero-scope were changed to the final 2,602 sprints / 911 zero-scope / 1,691 nonempty sprints.
</commit_message>
<xml_diff>
--- a/week-16-article-artifact-presentation/sprint_risk_presentation.pptx
+++ b/week-16-article-artifact-presentation/sprint_risk_presentation.pptx
@@ -2563,7 +2563,7 @@
                   <a:srgbClr val="1F2933"/>
                 </a:solidFill>
               </a:rPr>
-              <a:t>• 7-page conference paper and 9-page extended manuscript</a:t>
+              <a:t>• 6-page conference paper and supporting analysis package</a:t>
             </a:r>
             <a:endParaRPr lang="en-US" sz="1200" dirty="0"/>
           </a:p>
@@ -6538,7 +6538,7 @@
                   <a:srgbClr val="1F2933"/>
                 </a:solidFill>
               </a:rPr>
-              <a:t>Cluster 95% CI: .604-.783</a:t>
+              <a:t>Cluster 95% CI: .596-.786</a:t>
             </a:r>
             <a:endParaRPr lang="en-US" sz="1000" dirty="0"/>
           </a:p>
@@ -6671,7 +6671,7 @@
                   <a:srgbClr val="1F2933"/>
                 </a:solidFill>
               </a:rPr>
-              <a:t>Cluster 95% CI: .797-.914</a:t>
+              <a:t>Cluster 95% CI: .774-.911</a:t>
             </a:r>
             <a:endParaRPr lang="en-US" sz="1000" dirty="0"/>
           </a:p>

</xml_diff>